<commit_message>
feat: add native transitions to PPTX file
</commit_message>
<xml_diff>
--- a/wwwroot/ShareMeal_Presentation.pptx
+++ b/wwwroot/ShareMeal_Presentation.pptx
@@ -3591,6 +3591,9 @@
   <p:clrMapOvr>
     <a:masterClrMapping/>
   </p:clrMapOvr>
+  <p:transition spd="med">
+    <p:fade/>
+  </p:transition>
 </p:sld>
 </file>
 
@@ -5280,6 +5283,9 @@
   <p:clrMapOvr>
     <a:masterClrMapping/>
   </p:clrMapOvr>
+  <p:transition spd="med">
+    <p:fade/>
+  </p:transition>
 </p:sld>
 </file>
 
@@ -6512,6 +6518,9 @@
   <p:clrMapOvr>
     <a:masterClrMapping/>
   </p:clrMapOvr>
+  <p:transition spd="med">
+    <p:fade/>
+  </p:transition>
 </p:sld>
 </file>
 
@@ -7198,6 +7207,9 @@
   <p:clrMapOvr>
     <a:masterClrMapping/>
   </p:clrMapOvr>
+  <p:transition spd="med">
+    <p:fade/>
+  </p:transition>
 </p:sld>
 </file>
 
@@ -8851,6 +8863,9 @@
   <p:clrMapOvr>
     <a:masterClrMapping/>
   </p:clrMapOvr>
+  <p:transition spd="med">
+    <p:fade/>
+  </p:transition>
 </p:sld>
 </file>
 
@@ -9824,6 +9839,9 @@
   <p:clrMapOvr>
     <a:masterClrMapping/>
   </p:clrMapOvr>
+  <p:transition spd="med">
+    <p:fade/>
+  </p:transition>
 </p:sld>
 </file>
 
@@ -10867,6 +10885,9 @@
   <p:clrMapOvr>
     <a:masterClrMapping/>
   </p:clrMapOvr>
+  <p:transition spd="med">
+    <p:fade/>
+  </p:transition>
 </p:sld>
 </file>
 
@@ -12526,6 +12547,9 @@
   <p:clrMapOvr>
     <a:masterClrMapping/>
   </p:clrMapOvr>
+  <p:transition spd="med">
+    <p:fade/>
+  </p:transition>
 </p:sld>
 </file>
 
@@ -14029,6 +14053,9 @@
   <p:clrMapOvr>
     <a:masterClrMapping/>
   </p:clrMapOvr>
+  <p:transition spd="med">
+    <p:fade/>
+  </p:transition>
 </p:sld>
 </file>
 
@@ -16306,6 +16333,9 @@
   <p:clrMapOvr>
     <a:masterClrMapping/>
   </p:clrMapOvr>
+  <p:transition spd="med">
+    <p:fade/>
+  </p:transition>
 </p:sld>
 </file>
 
@@ -19078,6 +19108,9 @@
   <p:clrMapOvr>
     <a:masterClrMapping/>
   </p:clrMapOvr>
+  <p:transition spd="med">
+    <p:fade/>
+  </p:transition>
 </p:sld>
 </file>
 
@@ -20287,6 +20320,9 @@
   <p:clrMapOvr>
     <a:masterClrMapping/>
   </p:clrMapOvr>
+  <p:transition spd="med">
+    <p:fade/>
+  </p:transition>
 </p:sld>
 </file>
 

</xml_diff>

<commit_message>
fix: finalize system stability, sanitize db nulls, add smart MealBot AI fallback and deliverables
</commit_message>
<xml_diff>
--- a/wwwroot/ShareMeal_Presentation.pptx
+++ b/wwwroot/ShareMeal_Presentation.pptx
@@ -3631,7 +3631,7 @@
                 </a:solidFill>
                 <a:latin typeface="Calibri"/>
               </a:rPr>
-              <a:t>Prof. Kinat</a:t>
+              <a:t>Miss Kainat Sajid</a:t>
             </a:r>
           </a:p>
         </p:txBody>
@@ -3736,7 +3736,7 @@
                 </a:solidFill>
                 <a:latin typeface="Calibri"/>
               </a:rPr>
-              <a:t>Academic Session 2022–2026 • Final Project Defense</a:t>
+              <a:t>Academic Session 2024–2026 • Final Project Defense</a:t>
             </a:r>
           </a:p>
         </p:txBody>
@@ -6257,7 +6257,7 @@
                 </a:solidFill>
                 <a:latin typeface="Calibri"/>
               </a:rPr>
-              <a:t>Prof. Kinat</a:t>
+              <a:t>Miss Kainat Sajid</a:t>
             </a:r>
           </a:p>
         </p:txBody>

</xml_diff>